<commit_message>
Add project repo link to slides
</commit_message>
<xml_diff>
--- a/SnSe_Capstone_Slides.pptx
+++ b/SnSe_Capstone_Slides.pptx
@@ -5684,6 +5684,41 @@
           </a:prstGeom>
         </p:spPr>
       </p:pic>
+      <p:sp>
+        <p:nvSpPr>
+          <p:cNvPr id="7" name="TextBox 6"/>
+          <p:cNvSpPr txBox="1"/>
+          <p:nvPr/>
+        </p:nvSpPr>
+        <p:spPr>
+          <a:xfrm>
+            <a:off x="548640" y="6309360"/>
+            <a:ext cx="11064240" cy="365760"/>
+          </a:xfrm>
+          <a:prstGeom prst="rect">
+            <a:avLst/>
+          </a:prstGeom>
+          <a:noFill/>
+        </p:spPr>
+        <p:txBody>
+          <a:bodyPr wrap="square" anchor="t">
+            <a:spAutoFit/>
+          </a:bodyPr>
+          <a:lstStyle/>
+          <a:p>
+            <a:pPr algn="l"/>
+            <a:r>
+              <a:rPr sz="1300" b="0" i="1">
+                <a:solidFill>
+                  <a:srgbClr val="2E86AB"/>
+                </a:solidFill>
+                <a:latin typeface="Calibri"/>
+              </a:rPr>
+              <a:t>Code &amp; notebook: github.com/ShahiDDU/snse-bandgap-ml-capstone</a:t>
+            </a:r>
+          </a:p>
+        </p:txBody>
+      </p:sp>
     </p:spTree>
   </p:cSld>
   <p:clrMapOvr>

</xml_diff>

<commit_message>
Increase figure typography for presentation legibility (dataviz/scientific-slides guidance)
</commit_message>
<xml_diff>
--- a/SnSe_Capstone_Slides.pptx
+++ b/SnSe_Capstone_Slides.pptx
@@ -3783,15 +3783,15 @@
           <p:nvPr/>
         </p:nvPicPr>
         <p:blipFill>
-          <a:blip r:embed="rId4"/>
+          <a:blip r:embed="rId5"/>
           <a:stretch>
             <a:fillRect/>
           </a:stretch>
         </p:blipFill>
         <p:spPr>
           <a:xfrm>
-            <a:off x="3129515" y="1645920"/>
-            <a:ext cx="5902489" cy="4206240"/>
+            <a:off x="3129515" y="1858304"/>
+            <a:ext cx="5902489" cy="3781471"/>
           </a:xfrm>
           <a:prstGeom prst="rect">
             <a:avLst/>

</xml_diff>

<commit_message>
Recolor theme to teal/emerald + slate, expand slide and report content
</commit_message>
<xml_diff>
--- a/SnSe_Capstone_Slides.pptx
+++ b/SnSe_Capstone_Slides.pptx
@@ -1436,7 +1436,7 @@
             <a:r>
               <a:rPr lang="en-US" sz="4400" b="1" dirty="0">
                 <a:solidFill>
-                  <a:srgbClr val="1F3864"/>
+                  <a:srgbClr val="0E6B5C"/>
                 </a:solidFill>
                 <a:latin typeface="Calibri" pitchFamily="34" charset="0"/>
                 <a:ea typeface="Calibri" pitchFamily="34" charset="-122"/>
@@ -1553,7 +1553,7 @@
             <a:r>
               <a:rPr lang="en-US" sz="1600" i="1" dirty="0">
                 <a:solidFill>
-                  <a:srgbClr val="9C6500"/>
+                  <a:srgbClr val="4A5D68"/>
                 </a:solidFill>
                 <a:latin typeface="Calibri" pitchFamily="34" charset="0"/>
                 <a:ea typeface="Calibri" pitchFamily="34" charset="-122"/>
@@ -1702,7 +1702,7 @@
             <a:r>
               <a:rPr lang="en-US" sz="2700" b="1" dirty="0">
                 <a:solidFill>
-                  <a:srgbClr val="1F3864"/>
+                  <a:srgbClr val="0E6B5C"/>
                 </a:solidFill>
                 <a:latin typeface="Calibri" pitchFamily="34" charset="0"/>
                 <a:ea typeface="Calibri" pitchFamily="34" charset="-122"/>
@@ -1736,6 +1736,10 @@
             <a:prstDash val="solid"/>
           </a:ln>
         </p:spPr>
+        <p:txBody>
+          <a:bodyPr/>
+          <a:p/>
+        </p:txBody>
       </p:sp>
       <p:sp>
         <p:nvSpPr>
@@ -1746,13 +1750,13 @@
         <p:spPr>
           <a:xfrm>
             <a:off x="457200" y="1417320"/>
-            <a:ext cx="11247120" cy="2011680"/>
+            <a:ext cx="11247120" cy="4892040"/>
           </a:xfrm>
           <a:prstGeom prst="rect">
             <a:avLst/>
           </a:prstGeom>
           <a:solidFill>
-            <a:srgbClr val="FFF9E6"/>
+            <a:srgbClr val="E8F3F0"/>
           </a:solidFill>
           <a:ln w="9525">
             <a:solidFill>
@@ -1761,6 +1765,10 @@
             <a:prstDash val="solid"/>
           </a:ln>
         </p:spPr>
+        <p:txBody>
+          <a:bodyPr/>
+          <a:p/>
+        </p:txBody>
       </p:sp>
       <p:sp>
         <p:nvSpPr>
@@ -1780,7 +1788,7 @@
           <a:ln/>
         </p:spPr>
         <p:txBody>
-          <a:bodyPr wrap="square" lIns="0" tIns="0" rIns="0" bIns="0" rtlCol="0" anchor="ctr"/>
+          <a:bodyPr wrap="square" lIns="0" tIns="0" rIns="0" bIns="0" rtlCol="0" anchor="t"/>
           <a:lstStyle/>
           <a:p>
             <a:pPr indent="0" marL="0">
@@ -1789,7 +1797,7 @@
             <a:r>
               <a:rPr lang="en-US" sz="1200" b="1" i="1" dirty="0">
                 <a:solidFill>
-                  <a:srgbClr val="9C6500"/>
+                  <a:srgbClr val="4A5D68"/>
                 </a:solidFill>
                 <a:latin typeface="Calibri" pitchFamily="34" charset="0"/>
                 <a:ea typeface="Calibri" pitchFamily="34" charset="-122"/>
@@ -1810,7 +1818,7 @@
         <p:spPr>
           <a:xfrm>
             <a:off x="685800" y="1965960"/>
-            <a:ext cx="10789920" cy="1280160"/>
+            <a:ext cx="10789920" cy="4343400"/>
           </a:xfrm>
           <a:prstGeom prst="rect">
             <a:avLst/>
@@ -1819,7 +1827,7 @@
           <a:ln/>
         </p:spPr>
         <p:txBody>
-          <a:bodyPr wrap="square" lIns="0" tIns="0" rIns="0" bIns="0" rtlCol="0" anchor="ctr"/>
+          <a:bodyPr wrap="square" lIns="0" tIns="0" rIns="0" bIns="0" rtlCol="0" anchor="t"/>
           <a:lstStyle/>
           <a:p>
             <a:pPr indent="0" marL="0">
@@ -1828,13 +1836,13 @@
             <a:r>
               <a:rPr lang="en-US" sz="1600" i="1" dirty="0">
                 <a:solidFill>
-                  <a:srgbClr val="9C6500"/>
+                  <a:srgbClr val="4A5D68"/>
                 </a:solidFill>
                 <a:latin typeface="Calibri" pitchFamily="34" charset="0"/>
                 <a:ea typeface="Calibri" pitchFamily="34" charset="-122"/>
                 <a:cs typeface="Calibri" pitchFamily="34" charset="-120"/>
               </a:rPr>
-              <a:t>SnSe is one of the best-performing thermoelectric materials found in the last decade. A fast, composition-only screen lets researchers triage candidate dopants/alloys before committing to expensive DFT calculations.</a:t>
+              <a:t>SnSe is one of the best thermoelectric materials found in the last ten years — it turns heat into electricity efficiently. Scientists try adding small amounts of other elements, such as lead, sulfur, or silver, to make it work even better. But testing every possible combination in the lab, or with expensive supercomputer calculations (DFT), takes a lot of time and money. A quick computer model that only needs the chemical formula can act as a first filter — it tells scientists which combinations are worth testing further, before they spend time and money on slower methods. This project builds two such models: one that predicts metal-or-insulator, and one that predicts the band gap size for insulators.</a:t>
             </a:r>
             <a:endParaRPr lang="en-US" sz="1600" dirty="0"/>
           </a:p>
@@ -1977,7 +1985,7 @@
             <a:r>
               <a:rPr lang="en-US" sz="2700" b="1" dirty="0">
                 <a:solidFill>
-                  <a:srgbClr val="1F3864"/>
+                  <a:srgbClr val="0E6B5C"/>
                 </a:solidFill>
                 <a:latin typeface="Calibri" pitchFamily="34" charset="0"/>
                 <a:ea typeface="Calibri" pitchFamily="34" charset="-122"/>
@@ -2011,6 +2019,10 @@
             <a:prstDash val="solid"/>
           </a:ln>
         </p:spPr>
+        <p:txBody>
+          <a:bodyPr/>
+          <a:p/>
+        </p:txBody>
       </p:sp>
       <p:graphicFrame>
         <p:nvGraphicFramePr>
@@ -2550,14 +2562,14 @@
         </p:nvSpPr>
         <p:spPr>
           <a:xfrm>
-            <a:off x="457200" y="4937760"/>
-            <a:ext cx="11247120" cy="1097280"/>
+            <a:off x="457200" y="4434840"/>
+            <a:ext cx="11247120" cy="1874520"/>
           </a:xfrm>
           <a:prstGeom prst="rect">
             <a:avLst/>
           </a:prstGeom>
           <a:solidFill>
-            <a:srgbClr val="FFF9E6"/>
+            <a:srgbClr val="E8F3F0"/>
           </a:solidFill>
           <a:ln w="9525">
             <a:solidFill>
@@ -2566,6 +2578,10 @@
             <a:prstDash val="solid"/>
           </a:ln>
         </p:spPr>
+        <p:txBody>
+          <a:bodyPr/>
+          <a:p/>
+        </p:txBody>
       </p:sp>
       <p:sp>
         <p:nvSpPr>
@@ -2575,7 +2591,7 @@
         </p:nvSpPr>
         <p:spPr>
           <a:xfrm>
-            <a:off x="457200" y="5029200"/>
+            <a:off x="457200" y="4572000"/>
             <a:ext cx="7315200" cy="274320"/>
           </a:xfrm>
           <a:prstGeom prst="rect">
@@ -2585,7 +2601,7 @@
           <a:ln/>
         </p:spPr>
         <p:txBody>
-          <a:bodyPr wrap="square" lIns="0" tIns="0" rIns="0" bIns="0" rtlCol="0" anchor="ctr"/>
+          <a:bodyPr wrap="square" lIns="0" tIns="0" rIns="0" bIns="0" rtlCol="0" anchor="t"/>
           <a:lstStyle/>
           <a:p>
             <a:pPr indent="0" marL="0">
@@ -2594,7 +2610,7 @@
             <a:r>
               <a:rPr lang="en-US" sz="1200" b="1" i="1" dirty="0">
                 <a:solidFill>
-                  <a:srgbClr val="9C6500"/>
+                  <a:srgbClr val="4A5D68"/>
                 </a:solidFill>
                 <a:latin typeface="Calibri" pitchFamily="34" charset="0"/>
                 <a:ea typeface="Calibri" pitchFamily="34" charset="-122"/>
@@ -2614,8 +2630,8 @@
         </p:nvSpPr>
         <p:spPr>
           <a:xfrm>
-            <a:off x="685800" y="5349240"/>
-            <a:ext cx="10789920" cy="548640"/>
+            <a:off x="685800" y="4937760"/>
+            <a:ext cx="10789920" cy="1371600"/>
           </a:xfrm>
           <a:prstGeom prst="rect">
             <a:avLst/>
@@ -2624,7 +2640,7 @@
           <a:ln/>
         </p:spPr>
         <p:txBody>
-          <a:bodyPr wrap="square" lIns="0" tIns="0" rIns="0" bIns="0" rtlCol="0" anchor="ctr"/>
+          <a:bodyPr wrap="square" lIns="0" tIns="0" rIns="0" bIns="0" rtlCol="0" anchor="t"/>
           <a:lstStyle/>
           <a:p>
             <a:pPr indent="0" marL="0">
@@ -2633,13 +2649,13 @@
             <a:r>
               <a:rPr lang="en-US" sz="1500" i="1" dirty="0">
                 <a:solidFill>
-                  <a:srgbClr val="9C6500"/>
+                  <a:srgbClr val="4A5D68"/>
                 </a:solidFill>
                 <a:latin typeface="Calibri" pitchFamily="34" charset="0"/>
                 <a:ea typeface="Calibri" pitchFamily="34" charset="-122"/>
                 <a:cs typeface="Calibri" pitchFamily="34" charset="-120"/>
               </a:rPr>
-              <a:t>71% insulators / 29% metals — used for both classification and regression stages</a:t>
+              <a:t>We started with 220 raw results from the database and removed duplicate entries and any compound missing a band gap value, leaving 192 unique compounds. Each formula was turned into 132 numeric “features” — things like average electronegativity, atomic size, and valence electron count — using a tool called matminer. No crystal structure information was used, only the formula, which keeps the whole pipeline fast and simple. About seven in ten compounds are insulators and three in ten are metals; this imbalance is why we check model performance carefully rather than trusting accuracy alone.</a:t>
             </a:r>
             <a:endParaRPr lang="en-US" sz="1500" dirty="0"/>
           </a:p>
@@ -2782,7 +2798,7 @@
             <a:r>
               <a:rPr lang="en-US" sz="2700" b="1" dirty="0">
                 <a:solidFill>
-                  <a:srgbClr val="1F3864"/>
+                  <a:srgbClr val="0E6B5C"/>
                 </a:solidFill>
                 <a:latin typeface="Calibri" pitchFamily="34" charset="0"/>
                 <a:ea typeface="Calibri" pitchFamily="34" charset="-122"/>
@@ -2816,6 +2832,10 @@
             <a:prstDash val="solid"/>
           </a:ln>
         </p:spPr>
+        <p:txBody>
+          <a:bodyPr/>
+          <a:p/>
+        </p:txBody>
       </p:sp>
       <p:sp>
         <p:nvSpPr>
@@ -2826,13 +2846,13 @@
         <p:spPr>
           <a:xfrm>
             <a:off x="457200" y="1417320"/>
-            <a:ext cx="11247120" cy="1097280"/>
+            <a:ext cx="11247120" cy="4892040"/>
           </a:xfrm>
           <a:prstGeom prst="rect">
             <a:avLst/>
           </a:prstGeom>
           <a:solidFill>
-            <a:srgbClr val="FFF9E6"/>
+            <a:srgbClr val="E8F3F0"/>
           </a:solidFill>
           <a:ln w="9525">
             <a:solidFill>
@@ -2841,6 +2861,10 @@
             <a:prstDash val="solid"/>
           </a:ln>
         </p:spPr>
+        <p:txBody>
+          <a:bodyPr/>
+          <a:p/>
+        </p:txBody>
       </p:sp>
       <p:sp>
         <p:nvSpPr>
@@ -2850,7 +2874,7 @@
         </p:nvSpPr>
         <p:spPr>
           <a:xfrm>
-            <a:off x="457200" y="1508760"/>
+            <a:off x="457200" y="1554480"/>
             <a:ext cx="7315200" cy="274320"/>
           </a:xfrm>
           <a:prstGeom prst="rect">
@@ -2860,7 +2884,7 @@
           <a:ln/>
         </p:spPr>
         <p:txBody>
-          <a:bodyPr wrap="square" lIns="0" tIns="0" rIns="0" bIns="0" rtlCol="0" anchor="ctr"/>
+          <a:bodyPr wrap="square" lIns="0" tIns="0" rIns="0" bIns="0" rtlCol="0" anchor="t"/>
           <a:lstStyle/>
           <a:p>
             <a:pPr indent="0" marL="0">
@@ -2869,7 +2893,7 @@
             <a:r>
               <a:rPr lang="en-US" sz="1200" b="1" i="1" dirty="0">
                 <a:solidFill>
-                  <a:srgbClr val="9C6500"/>
+                  <a:srgbClr val="4A5D68"/>
                 </a:solidFill>
                 <a:latin typeface="Calibri" pitchFamily="34" charset="0"/>
                 <a:ea typeface="Calibri" pitchFamily="34" charset="-122"/>
@@ -2889,8 +2913,8 @@
         </p:nvSpPr>
         <p:spPr>
           <a:xfrm>
-            <a:off x="685800" y="1828800"/>
-            <a:ext cx="10789920" cy="548640"/>
+            <a:off x="685800" y="2011680"/>
+            <a:ext cx="10789920" cy="4251960"/>
           </a:xfrm>
           <a:prstGeom prst="rect">
             <a:avLst/>
@@ -2899,7 +2923,7 @@
           <a:ln/>
         </p:spPr>
         <p:txBody>
-          <a:bodyPr wrap="square" lIns="0" tIns="0" rIns="0" bIns="0" rtlCol="0" anchor="ctr"/>
+          <a:bodyPr wrap="square" lIns="0" tIns="0" rIns="0" bIns="0" rtlCol="0" anchor="t"/>
           <a:lstStyle/>
           <a:p>
             <a:pPr indent="0" marL="0">
@@ -2908,13 +2932,13 @@
             <a:r>
               <a:rPr lang="en-US" sz="1500" i="1" dirty="0">
                 <a:solidFill>
-                  <a:srgbClr val="9C6500"/>
+                  <a:srgbClr val="4A5D68"/>
                 </a:solidFill>
                 <a:latin typeface="Calibri" pitchFamily="34" charset="0"/>
                 <a:ea typeface="Calibri" pitchFamily="34" charset="-122"/>
                 <a:cs typeface="Calibri" pitchFamily="34" charset="-120"/>
               </a:rPr>
-              <a:t>5-fold cross-validation (mean ± std) — dataset small relative to 132 features. Chosen because Random Forest handles nonlinear composition-property relationships and gives feature importances for free.</a:t>
+              <a:t>We build two models. First, a classifier decides whether a compound is a metal or an insulator — we compare a simple method (Logistic Regression) against a more flexible one (Random Forest, 300 decision trees) to see which works better. Second, for compounds that are insulators, a Random Forest regressor predicts the actual band gap value in electron-volts (eV). Random Forest is a good default for this kind of chemistry data because it captures curved, non-obvious relationships between composition and properties, and it tells us afterward which features mattered most. Because we only have a few hundred compounds compared to 132 features, testing on a single random split can give a misleading score. Instead we use 5-fold cross-validation: the data is split into 5 groups, the model trains on 4 and is tested on the 1 left out, repeated 5 times so every compound gets tested once — giving a far more trustworthy average score.</a:t>
             </a:r>
             <a:endParaRPr lang="en-US" sz="1500" dirty="0"/>
           </a:p>
@@ -3057,7 +3081,7 @@
             <a:r>
               <a:rPr lang="en-US" sz="2700" b="1" dirty="0">
                 <a:solidFill>
-                  <a:srgbClr val="1F3864"/>
+                  <a:srgbClr val="0E6B5C"/>
                 </a:solidFill>
                 <a:latin typeface="Calibri" pitchFamily="34" charset="0"/>
                 <a:ea typeface="Calibri" pitchFamily="34" charset="-122"/>
@@ -3091,6 +3115,10 @@
             <a:prstDash val="solid"/>
           </a:ln>
         </p:spPr>
+        <p:txBody>
+          <a:bodyPr/>
+          <a:p/>
+        </p:txBody>
       </p:sp>
       <p:pic>
         <p:nvPicPr>
@@ -3622,7 +3650,7 @@
             <a:r>
               <a:rPr lang="en-US" sz="2700" b="1" dirty="0">
                 <a:solidFill>
-                  <a:srgbClr val="1F3864"/>
+                  <a:srgbClr val="0E6B5C"/>
                 </a:solidFill>
                 <a:latin typeface="Calibri" pitchFamily="34" charset="0"/>
                 <a:ea typeface="Calibri" pitchFamily="34" charset="-122"/>
@@ -3656,6 +3684,10 @@
             <a:prstDash val="solid"/>
           </a:ln>
         </p:spPr>
+        <p:txBody>
+          <a:bodyPr/>
+          <a:p/>
+        </p:txBody>
       </p:sp>
       <p:sp>
         <p:nvSpPr>
@@ -3783,7 +3815,7 @@
           <p:nvPr/>
         </p:nvPicPr>
         <p:blipFill>
-          <a:blip r:embed="rId5"/>
+          <a:blip r:embed="rId6"/>
           <a:stretch>
             <a:fillRect/>
           </a:stretch>
@@ -3857,7 +3889,7 @@
             <a:r>
               <a:rPr lang="en-US" sz="2700" b="1" dirty="0">
                 <a:solidFill>
-                  <a:srgbClr val="1F3864"/>
+                  <a:srgbClr val="0E6B5C"/>
                 </a:solidFill>
                 <a:latin typeface="Calibri" pitchFamily="34" charset="0"/>
                 <a:ea typeface="Calibri" pitchFamily="34" charset="-122"/>
@@ -3891,6 +3923,10 @@
             <a:prstDash val="solid"/>
           </a:ln>
         </p:spPr>
+        <p:txBody>
+          <a:bodyPr/>
+          <a:p/>
+        </p:txBody>
       </p:sp>
       <p:sp>
         <p:nvSpPr>
@@ -3901,13 +3937,13 @@
         <p:spPr>
           <a:xfrm>
             <a:off x="457200" y="1417320"/>
-            <a:ext cx="11247120" cy="1828800"/>
+            <a:ext cx="11247120" cy="4892040"/>
           </a:xfrm>
           <a:prstGeom prst="rect">
             <a:avLst/>
           </a:prstGeom>
           <a:solidFill>
-            <a:srgbClr val="FFF9E6"/>
+            <a:srgbClr val="E8F3F0"/>
           </a:solidFill>
           <a:ln w="9525">
             <a:solidFill>
@@ -3916,6 +3952,10 @@
             <a:prstDash val="solid"/>
           </a:ln>
         </p:spPr>
+        <p:txBody>
+          <a:bodyPr/>
+          <a:p/>
+        </p:txBody>
       </p:sp>
       <p:sp>
         <p:nvSpPr>
@@ -3935,7 +3975,7 @@
           <a:ln/>
         </p:spPr>
         <p:txBody>
-          <a:bodyPr wrap="square" lIns="0" tIns="0" rIns="0" bIns="0" rtlCol="0" anchor="ctr"/>
+          <a:bodyPr wrap="square" lIns="0" tIns="0" rIns="0" bIns="0" rtlCol="0" anchor="t"/>
           <a:lstStyle/>
           <a:p>
             <a:pPr indent="0" marL="0">
@@ -3944,13 +3984,13 @@
             <a:r>
               <a:rPr lang="en-US" sz="1200" b="1" i="1" dirty="0">
                 <a:solidFill>
-                  <a:srgbClr val="9C6500"/>
+                  <a:srgbClr val="4A5D68"/>
                 </a:solidFill>
                 <a:latin typeface="Calibri" pitchFamily="34" charset="0"/>
                 <a:ea typeface="Calibri" pitchFamily="34" charset="-122"/>
                 <a:cs typeface="Calibri" pitchFamily="34" charset="-120"/>
               </a:rPr>
-              <a:t>Composition-only Random Forest reaches ~80% classification accuracy and ~0.36 eV band-gap MAE — a useful fast screen, not a DFT replacement.</a:t>
+              <a:t>Using only the chemical formula, our Random Forest model correctly labels a compound as metal or insulator about 80% of the time, and predicts the band gap of insulators to within about 0.36 eV on average — not perfect, but a genuinely useful first filter for narrowing down candidates before expensive DFT calculations or lab experiments.</a:t>
             </a:r>
             <a:endParaRPr lang="en-US" sz="1200" dirty="0"/>
           </a:p>
@@ -3964,8 +4004,8 @@
         </p:nvSpPr>
         <p:spPr>
           <a:xfrm>
-            <a:off x="685800" y="1965960"/>
-            <a:ext cx="10789920" cy="1097280"/>
+            <a:off x="685800" y="2240280"/>
+            <a:ext cx="10789920" cy="4023360"/>
           </a:xfrm>
           <a:prstGeom prst="rect">
             <a:avLst/>
@@ -3974,7 +4014,7 @@
           <a:ln/>
         </p:spPr>
         <p:txBody>
-          <a:bodyPr wrap="square" lIns="0" tIns="0" rIns="0" bIns="0" rtlCol="0" anchor="ctr"/>
+          <a:bodyPr wrap="square" lIns="0" tIns="0" rIns="0" bIns="0" rtlCol="0" anchor="t"/>
           <a:lstStyle/>
           <a:p>
             <a:pPr indent="0" marL="0">
@@ -3983,13 +4023,13 @@
             <a:r>
               <a:rPr lang="en-US" sz="1600" i="1" dirty="0">
                 <a:solidFill>
-                  <a:srgbClr val="9C6500"/>
+                  <a:srgbClr val="4A5D68"/>
                 </a:solidFill>
                 <a:latin typeface="Calibri" pitchFamily="34" charset="0"/>
                 <a:ea typeface="Calibri" pitchFamily="34" charset="-122"/>
                 <a:cs typeface="Calibri" pitchFamily="34" charset="-120"/>
               </a:rPr>
-              <a:t>Limitation: composition-only features can't distinguish polymorphs (e.g. SnSe's room-temp vs. high-T phase); the ~190-compound dataset is small relative to 132 features.  |  Code &amp; notebook: github.com/ShahiDDU/snse-bandgap-ml-capstone</a:t>
+              <a:t>Limitations: the model only sees the chemical formula, so it cannot tell apart two compounds with the same formula but different crystal structures — SnSe's everyday room-temperature form and its high-temperature form get treated as identical, even though their band gaps differ. The dataset is also fairly small (about 190 compounds) compared to the 132 numbers describing each one, so results can vary between different train/test splits — which is why we relied on 5-fold cross-validation rather than a single split. A natural next step: add structural information, or gather more compounds from the wider family of similar materials (SnS, SnTe, PbSe, and others).  |  Code &amp; notebook: github.com/ShahiDDU/snse-bandgap-ml-capstone</a:t>
             </a:r>
             <a:endParaRPr lang="en-US" sz="1600" dirty="0"/>
           </a:p>

</xml_diff>

<commit_message>
Add step-by-step teaching explanations (Notice/Quick Check cells) to notebook and numbered walkthrough to slides
</commit_message>
<xml_diff>
--- a/SnSe_Capstone_Slides.pptx
+++ b/SnSe_Capstone_Slides.pptx
@@ -2616,7 +2616,7 @@
                 <a:ea typeface="Calibri" pitchFamily="34" charset="-122"/>
                 <a:cs typeface="Calibri" pitchFamily="34" charset="-120"/>
               </a:rPr>
-              <a:t>192 unique Sn-Se-based compounds, 132 composition features</a:t>
+              <a:t>Step 1: Query the database  →  Step 2: Clean the results  →  Step 3: Turn formulas into features</a:t>
             </a:r>
             <a:endParaRPr lang="en-US" sz="1200" dirty="0"/>
           </a:p>
@@ -2655,7 +2655,7 @@
                 <a:ea typeface="Calibri" pitchFamily="34" charset="-122"/>
                 <a:cs typeface="Calibri" pitchFamily="34" charset="-120"/>
               </a:rPr>
-              <a:t>We started with 220 raw results from the database and removed duplicate entries and any compound missing a band gap value, leaving 192 unique compounds. Each formula was turned into 132 numeric “features” — things like average electronegativity, atomic size, and valence electron count — using a tool called matminer. No crystal structure information was used, only the formula, which keeps the whole pipeline fast and simple. About seven in ten compounds are insulators and three in ten are metals; this imbalance is why we check model performance carefully rather than trusting accuracy alone.</a:t>
+              <a:t>Step 1 — Query: pulled 220 Sn-Se-based compounds live from the Materials Project API. Step 2 — Clean: removed duplicate formulas and entries with no computed band gap, leaving 192 unique compounds. Step 3 — Featurize: turned each chemical formula into 132 numeric features (electronegativity, atomic size, valence electron count, and more) using matminer — no crystal structure needed, just the formula. About seven in ten compounds ended up insulators and three in ten metals.</a:t>
             </a:r>
             <a:endParaRPr lang="en-US" sz="1500" dirty="0"/>
           </a:p>
@@ -2899,7 +2899,7 @@
                 <a:ea typeface="Calibri" pitchFamily="34" charset="-122"/>
                 <a:cs typeface="Calibri" pitchFamily="34" charset="-120"/>
               </a:rPr>
-              <a:t>Classification: Logistic Regression vs. Random Forest (300 trees). Regression: Random Forest (300 trees) on insulators only.</a:t>
+              <a:t>Step 4: Split the data  →  Step 5: Train two models  →  Step 6: Evaluate carefully</a:t>
             </a:r>
             <a:endParaRPr lang="en-US" sz="1200" dirty="0"/>
           </a:p>
@@ -2938,7 +2938,7 @@
                 <a:ea typeface="Calibri" pitchFamily="34" charset="-122"/>
                 <a:cs typeface="Calibri" pitchFamily="34" charset="-120"/>
               </a:rPr>
-              <a:t>We build two models. First, a classifier decides whether a compound is a metal or an insulator — we compare a simple method (Logistic Regression) against a more flexible one (Random Forest, 300 decision trees) to see which works better. Second, for compounds that are insulators, a Random Forest regressor predicts the actual band gap value in electron-volts (eV). Random Forest is a good default for this kind of chemistry data because it captures curved, non-obvious relationships between composition and properties, and it tells us afterward which features mattered most. Because we only have a few hundred compounds compared to 132 features, testing on a single random split can give a misleading score. Instead we use 5-fold cross-validation: the data is split into 5 groups, the model trains on 4 and is tested on the 1 left out, repeated 5 times so every compound gets tested once — giving a far more trustworthy average score.</a:t>
+              <a:t>Step 4 — Split: a stratified 80/20 train/test split for classification (153 training, 39 test compounds). Step 5 — Train: Logistic Regression vs. Random Forest (300 trees) to classify metal-or-insulator; a separate Random Forest (300 trees) regresses the band gap value on the insulator subset only. Step 6 — Evaluate: with only 192 compounds against 132 features, a single train/test split is noisy — so we use 5-fold cross-validation (5 different splits, averaged) as the trustworthy number throughout, not just the single-split result.</a:t>
             </a:r>
             <a:endParaRPr lang="en-US" sz="1500" dirty="0"/>
           </a:p>

</xml_diff>